<commit_message>
feat(presentation): replace Slide 8 budget with comprehensive risk management and future safeguards
</commit_message>
<xml_diff>
--- a/archive/RetailSync_Team_Sharing_Pack/03_Defense_Presentation_Deck.pptx
+++ b/archive/RetailSync_Team_Sharing_Pack/03_Defense_Presentation_Deck.pptx
@@ -8028,7 +8028,7 @@
               </a:defRPr>
             </a:pPr>
             <a:r>
-              <a:t>FINANCIAL FEASIBILITY &amp; ENGINEERING SAFEGUARDS</a:t>
+              <a:t>ENGINEERING RISK MANAGEMENT &amp; FUTURE-PROOF SOLUTIONS</a:t>
             </a:r>
           </a:p>
         </p:txBody>
@@ -8064,7 +8064,7 @@
               </a:defRPr>
             </a:pPr>
             <a:r>
-              <a:t>Budget Estimation &amp; Risk Mitigation</a:t>
+              <a:t>Risk Assessment, Safeguards &amp; Future Architecture</a:t>
             </a:r>
           </a:p>
         </p:txBody>
@@ -8195,7 +8195,7 @@
         <p:spPr>
           <a:xfrm>
             <a:off x="731520" y="1417320"/>
-            <a:ext cx="5166360" cy="4800600"/>
+            <a:ext cx="5193792" cy="4800600"/>
           </a:xfrm>
           <a:prstGeom prst="roundRect">
             <a:avLst/>
@@ -8240,7 +8240,7 @@
         <p:spPr>
           <a:xfrm>
             <a:off x="960120" y="1554480"/>
-            <a:ext cx="4709160" cy="4572000"/>
+            <a:ext cx="4736592" cy="4480560"/>
           </a:xfrm>
           <a:prstGeom prst="rect">
             <a:avLst/>
@@ -8256,21 +8256,53 @@
             <a:pPr>
               <a:defRPr sz="1200" b="1">
                 <a:solidFill>
-                  <a:srgbClr val="0284C7"/>
-                </a:solidFill>
-                <a:latin typeface="Calibri"/>
-              </a:defRPr>
-            </a:pPr>
-            <a:r>
-              <a:t>FRUGAL PROTOTYPING BUDGET (BDT)</a:t>
+                  <a:srgbClr val="EF4444"/>
+                </a:solidFill>
+                <a:latin typeface="Calibri"/>
+              </a:defRPr>
+            </a:pPr>
+            <a:r>
+              <a:t>OPERATIONAL &amp; CONCURRENCY SAFEGUARDS</a:t>
             </a:r>
           </a:p>
           <a:p>
             <a:pPr>
               <a:spcBef>
-                <a:spcPts val="300"/>
+                <a:spcPts val="800"/>
               </a:spcBef>
-              <a:defRPr sz="1100">
+              <a:defRPr sz="1100" b="1">
+                <a:solidFill>
+                  <a:srgbClr val="EF4444"/>
+                </a:solidFill>
+                <a:latin typeface="Calibri"/>
+              </a:defRPr>
+            </a:pPr>
+            <a:r>
+              <a:t>⚠  Multi-Till Rush-Hour Race Conditions</a:t>
+            </a:r>
+          </a:p>
+          <a:p>
+            <a:pPr>
+              <a:spcBef>
+                <a:spcPts val="100"/>
+              </a:spcBef>
+              <a:defRPr sz="950">
+                <a:solidFill>
+                  <a:srgbClr val="475569"/>
+                </a:solidFill>
+                <a:latin typeface="Calibri"/>
+              </a:defRPr>
+            </a:pPr>
+            <a:r>
+              <a:t>Risk: Simultaneous checkout at 5+ tills causes overselling and double-allocation of the same lot.</a:t>
+            </a:r>
+          </a:p>
+          <a:p>
+            <a:pPr>
+              <a:spcBef>
+                <a:spcPts val="200"/>
+              </a:spcBef>
+              <a:defRPr sz="950">
                 <a:solidFill>
                   <a:srgbClr val="0F172A"/>
                 </a:solidFill>
@@ -8278,15 +8310,47 @@
               </a:defRPr>
             </a:pPr>
             <a:r>
-              <a:t>• Cloud VPS Hosting (FastAPI &amp; PostgreSQL): 4,500 BDT</a:t>
+              <a:t>✓ Solution &amp; Future Safeguard: PostgreSQL row-level locks (SELECT FOR UPDATE SKIP LOCKED) ensure atomic batch deduction in &lt;2.0s. Future: Distributed Redis locking for cluster scale.</a:t>
             </a:r>
           </a:p>
           <a:p>
             <a:pPr>
               <a:spcBef>
-                <a:spcPts val="300"/>
+                <a:spcPts val="800"/>
               </a:spcBef>
-              <a:defRPr sz="1100">
+              <a:defRPr sz="1100" b="1">
+                <a:solidFill>
+                  <a:srgbClr val="EF4444"/>
+                </a:solidFill>
+                <a:latin typeface="Calibri"/>
+              </a:defRPr>
+            </a:pPr>
+            <a:r>
+              <a:t>⚠  Intermittent Network Outages at Checkout</a:t>
+            </a:r>
+          </a:p>
+          <a:p>
+            <a:pPr>
+              <a:spcBef>
+                <a:spcPts val="100"/>
+              </a:spcBef>
+              <a:defRPr sz="950">
+                <a:solidFill>
+                  <a:srgbClr val="475569"/>
+                </a:solidFill>
+                <a:latin typeface="Calibri"/>
+              </a:defRPr>
+            </a:pPr>
+            <a:r>
+              <a:t>Risk: Local ISP or Wi-Fi drops disconnect cash registers from the central database.</a:t>
+            </a:r>
+          </a:p>
+          <a:p>
+            <a:pPr>
+              <a:spcBef>
+                <a:spcPts val="200"/>
+              </a:spcBef>
+              <a:defRPr sz="950">
                 <a:solidFill>
                   <a:srgbClr val="0F172A"/>
                 </a:solidFill>
@@ -8294,15 +8358,47 @@
               </a:defRPr>
             </a:pPr>
             <a:r>
-              <a:t>• 1D/2D Handheld Barcode Scanners (x2): 3,800 BDT</a:t>
+              <a:t>✓ Solution &amp; Future Safeguard: Client-side offline transaction buffer with automatic sync queue upon reconnect. Future: PWA offline-first service worker architecture.</a:t>
             </a:r>
           </a:p>
           <a:p>
             <a:pPr>
               <a:spcBef>
-                <a:spcPts val="300"/>
+                <a:spcPts val="800"/>
               </a:spcBef>
-              <a:defRPr sz="1100">
+              <a:defRPr sz="1100" b="1">
+                <a:solidFill>
+                  <a:srgbClr val="EF4444"/>
+                </a:solidFill>
+                <a:latin typeface="Calibri"/>
+              </a:defRPr>
+            </a:pPr>
+            <a:r>
+              <a:t>⚠  Barcode Scanning Degradation on Chilled Items</a:t>
+            </a:r>
+          </a:p>
+          <a:p>
+            <a:pPr>
+              <a:spcBef>
+                <a:spcPts val="100"/>
+              </a:spcBef>
+              <a:defRPr sz="950">
+                <a:solidFill>
+                  <a:srgbClr val="475569"/>
+                </a:solidFill>
+                <a:latin typeface="Calibri"/>
+              </a:defRPr>
+            </a:pPr>
+            <a:r>
+              <a:t>Risk: Moisture condensation on milk/meat pouches makes 1D barcodes unreadable.</a:t>
+            </a:r>
+          </a:p>
+          <a:p>
+            <a:pPr>
+              <a:spcBef>
+                <a:spcPts val="200"/>
+              </a:spcBef>
+              <a:defRPr sz="950">
                 <a:solidFill>
                   <a:srgbClr val="0F172A"/>
                 </a:solidFill>
@@ -8310,85 +8406,7 @@
               </a:defRPr>
             </a:pPr>
             <a:r>
-              <a:t>• Thermal ESC/POS Receipt Printer (x1): 4,200 BDT</a:t>
-            </a:r>
-          </a:p>
-          <a:p>
-            <a:pPr>
-              <a:spcBef>
-                <a:spcPts val="300"/>
-              </a:spcBef>
-              <a:defRPr sz="1100">
-                <a:solidFill>
-                  <a:srgbClr val="0F172A"/>
-                </a:solidFill>
-                <a:latin typeface="Calibri"/>
-              </a:defRPr>
-            </a:pPr>
-            <a:r>
-              <a:t>• Domain Name &amp; SSL Security (1 Year): 1,800 BDT</a:t>
-            </a:r>
-          </a:p>
-          <a:p>
-            <a:pPr>
-              <a:spcBef>
-                <a:spcPts val="300"/>
-              </a:spcBef>
-              <a:defRPr sz="1100">
-                <a:solidFill>
-                  <a:srgbClr val="0F172A"/>
-                </a:solidFill>
-                <a:latin typeface="Calibri"/>
-              </a:defRPr>
-            </a:pPr>
-            <a:r>
-              <a:t>• FMCG Test Batches &amp; Prototype Materials: 2,200 BDT</a:t>
-            </a:r>
-          </a:p>
-          <a:p>
-            <a:pPr>
-              <a:spcBef>
-                <a:spcPts val="300"/>
-              </a:spcBef>
-              <a:defRPr sz="1100">
-                <a:solidFill>
-                  <a:srgbClr val="0F172A"/>
-                </a:solidFill>
-                <a:latin typeface="Calibri"/>
-              </a:defRPr>
-            </a:pPr>
-            <a:r>
-              <a:t>• Contingency &amp; Miscellaneous: 2,500 BDT</a:t>
-            </a:r>
-          </a:p>
-          <a:p>
-            <a:br/>
-            <a:pPr>
-              <a:defRPr sz="1300" b="1">
-                <a:solidFill>
-                  <a:srgbClr val="0284C7"/>
-                </a:solidFill>
-                <a:latin typeface="Consolas"/>
-              </a:defRPr>
-            </a:pPr>
-            <a:r>
-              <a:t>TOTAL ESTIMATE: ≈ 22,500 BDT (~$190 USD)</a:t>
-            </a:r>
-          </a:p>
-          <a:p>
-            <a:pPr>
-              <a:spcBef>
-                <a:spcPts val="400"/>
-              </a:spcBef>
-              <a:defRPr sz="1050">
-                <a:solidFill>
-                  <a:srgbClr val="475569"/>
-                </a:solidFill>
-                <a:latin typeface="Calibri"/>
-              </a:defRPr>
-            </a:pPr>
-            <a:r>
-              <a:t>100% Open-Source Stack: Zero recurring enterprise software fees. Preventing a single batch expiry incident (≈ ৳30,000) recovers the entire setup cost.</a:t>
+              <a:t>✓ Solution &amp; Future Safeguard: Audio scan validation, regex string normalization, and rapid 3-letter manual SKU fallback. Future: 2D DataMatrix and HF-RFID pallet tags.</a:t>
             </a:r>
           </a:p>
         </p:txBody>
@@ -8447,7 +8465,7 @@
         <p:spPr>
           <a:xfrm>
             <a:off x="6492240" y="1554480"/>
-            <a:ext cx="4736592" cy="4572000"/>
+            <a:ext cx="4736592" cy="4480560"/>
           </a:xfrm>
           <a:prstGeom prst="rect">
             <a:avLst/>
@@ -8463,34 +8481,53 @@
             <a:pPr>
               <a:defRPr sz="1200" b="1">
                 <a:solidFill>
-                  <a:srgbClr val="EF4444"/>
-                </a:solidFill>
-                <a:latin typeface="Calibri"/>
-              </a:defRPr>
-            </a:pPr>
-            <a:r>
-              <a:t>RISKS &amp; MITIGATION MATRIX</a:t>
+                  <a:srgbClr val="0284C7"/>
+                </a:solidFill>
+                <a:latin typeface="Calibri"/>
+              </a:defRPr>
+            </a:pPr>
+            <a:r>
+              <a:t>SUPPLY CHAIN, FOOD SAFETY &amp; SCALABILITY</a:t>
             </a:r>
           </a:p>
           <a:p>
             <a:pPr>
               <a:spcBef>
-                <a:spcPts val="400"/>
+                <a:spcPts val="800"/>
               </a:spcBef>
               <a:defRPr sz="1100" b="1">
                 <a:solidFill>
-                  <a:srgbClr val="EF4444"/>
-                </a:solidFill>
-                <a:latin typeface="Calibri"/>
-              </a:defRPr>
-            </a:pPr>
-            <a:r>
-              <a:t>⚠  Concurrency Collisions during peak rush</a:t>
-            </a:r>
-          </a:p>
-          <a:p>
-            <a:pPr>
-              <a:defRPr sz="1000">
+                  <a:srgbClr val="0B1F3A"/>
+                </a:solidFill>
+                <a:latin typeface="Calibri"/>
+              </a:defRPr>
+            </a:pPr>
+            <a:r>
+              <a:t>⚠  Distributor Delays &amp; Festival Demand Surges</a:t>
+            </a:r>
+          </a:p>
+          <a:p>
+            <a:pPr>
+              <a:spcBef>
+                <a:spcPts val="100"/>
+              </a:spcBef>
+              <a:defRPr sz="950">
+                <a:solidFill>
+                  <a:srgbClr val="475569"/>
+                </a:solidFill>
+                <a:latin typeface="Calibri"/>
+              </a:defRPr>
+            </a:pPr>
+            <a:r>
+              <a:t>Risk: Local supply chain volatility and festival surges (Eid/Ramadan) trigger stockouts.</a:t>
+            </a:r>
+          </a:p>
+          <a:p>
+            <a:pPr>
+              <a:spcBef>
+                <a:spcPts val="200"/>
+              </a:spcBef>
+              <a:defRPr sz="950">
                 <a:solidFill>
                   <a:srgbClr val="0F172A"/>
                 </a:solidFill>
@@ -8498,28 +8535,47 @@
               </a:defRPr>
             </a:pPr>
             <a:r>
-              <a:t>✓ PostgreSQL row-level locking (SELECT FOR UPDATE SKIP LOCKED) with atomic commit.</a:t>
+              <a:t>✓ Solution &amp; Future Safeguard: Greasley Stochastic Safety Stock (SS = Z·√(L·σd² + d²·σL²)) with 1-click stress presets (1.4x, 2.5x). Future: Automated vendor EDI purchase order triggers.</a:t>
             </a:r>
           </a:p>
           <a:p>
             <a:pPr>
               <a:spcBef>
-                <a:spcPts val="400"/>
+                <a:spcPts val="800"/>
               </a:spcBef>
               <a:defRPr sz="1100" b="1">
                 <a:solidFill>
-                  <a:srgbClr val="EF4444"/>
-                </a:solidFill>
-                <a:latin typeface="Calibri"/>
-              </a:defRPr>
-            </a:pPr>
-            <a:r>
-              <a:t>⚠  Intermittent Network Outages at checkout</a:t>
-            </a:r>
-          </a:p>
-          <a:p>
-            <a:pPr>
-              <a:defRPr sz="1000">
+                  <a:srgbClr val="0B1F3A"/>
+                </a:solidFill>
+                <a:latin typeface="Calibri"/>
+              </a:defRPr>
+            </a:pPr>
+            <a:r>
+              <a:t>⚠  Food Safety Non-Compliance (BFSA 2013)</a:t>
+            </a:r>
+          </a:p>
+          <a:p>
+            <a:pPr>
+              <a:spcBef>
+                <a:spcPts val="100"/>
+              </a:spcBef>
+              <a:defRPr sz="950">
+                <a:solidFill>
+                  <a:srgbClr val="475569"/>
+                </a:solidFill>
+                <a:latin typeface="Calibri"/>
+              </a:defRPr>
+            </a:pPr>
+            <a:r>
+              <a:t>Risk: Manual oversight allowing expired or near-expiry batches on retail shelves.</a:t>
+            </a:r>
+          </a:p>
+          <a:p>
+            <a:pPr>
+              <a:spcBef>
+                <a:spcPts val="200"/>
+              </a:spcBef>
+              <a:defRPr sz="950">
                 <a:solidFill>
                   <a:srgbClr val="0F172A"/>
                 </a:solidFill>
@@ -8527,28 +8583,47 @@
               </a:defRPr>
             </a:pPr>
             <a:r>
-              <a:t>✓ Client-side offline buffering with automatic sync queue upon reconnect.</a:t>
+              <a:t>✓ Solution &amp; Future Safeguard: Hard-coded 65% residual shelf-life receiving gate and automated FEFO allocation. Future: IoT cold-chain sensor integration with automatic thermal anomaly alerts.</a:t>
             </a:r>
           </a:p>
           <a:p>
             <a:pPr>
               <a:spcBef>
-                <a:spcPts val="400"/>
+                <a:spcPts val="800"/>
               </a:spcBef>
               <a:defRPr sz="1100" b="1">
                 <a:solidFill>
-                  <a:srgbClr val="EF4444"/>
-                </a:solidFill>
-                <a:latin typeface="Calibri"/>
-              </a:defRPr>
-            </a:pPr>
-            <a:r>
-              <a:t>⚠  Damaged Barcode Labels on cold products</a:t>
-            </a:r>
-          </a:p>
-          <a:p>
-            <a:pPr>
-              <a:defRPr sz="1000">
+                  <a:srgbClr val="0B1F3A"/>
+                </a:solidFill>
+                <a:latin typeface="Calibri"/>
+              </a:defRPr>
+            </a:pPr>
+            <a:r>
+              <a:t>⚠  Multi-Branch Growth &amp; Data Synchronization Lag</a:t>
+            </a:r>
+          </a:p>
+          <a:p>
+            <a:pPr>
+              <a:spcBef>
+                <a:spcPts val="100"/>
+              </a:spcBef>
+              <a:defRPr sz="950">
+                <a:solidFill>
+                  <a:srgbClr val="475569"/>
+                </a:solidFill>
+                <a:latin typeface="Calibri"/>
+              </a:defRPr>
+            </a:pPr>
+            <a:r>
+              <a:t>Risk: Expanding from single store to regional chain creates inventory sync bottlenecks.</a:t>
+            </a:r>
+          </a:p>
+          <a:p>
+            <a:pPr>
+              <a:spcBef>
+                <a:spcPts val="200"/>
+              </a:spcBef>
+              <a:defRPr sz="950">
                 <a:solidFill>
                   <a:srgbClr val="0F172A"/>
                 </a:solidFill>
@@ -8556,65 +8631,7 @@
               </a:defRPr>
             </a:pPr>
             <a:r>
-              <a:t>✓ Audio tone confirmation, regex string cleaning, and manual SKU fallback.</a:t>
-            </a:r>
-          </a:p>
-          <a:p>
-            <a:pPr>
-              <a:spcBef>
-                <a:spcPts val="400"/>
-              </a:spcBef>
-              <a:defRPr sz="1100" b="1">
-                <a:solidFill>
-                  <a:srgbClr val="EF4444"/>
-                </a:solidFill>
-                <a:latin typeface="Calibri"/>
-              </a:defRPr>
-            </a:pPr>
-            <a:r>
-              <a:t>⚠  Festival Demand Surges (Eid/Ramadan)</a:t>
-            </a:r>
-          </a:p>
-          <a:p>
-            <a:pPr>
-              <a:defRPr sz="1000">
-                <a:solidFill>
-                  <a:srgbClr val="0F172A"/>
-                </a:solidFill>
-                <a:latin typeface="Calibri"/>
-              </a:defRPr>
-            </a:pPr>
-            <a:r>
-              <a:t>✓ Greasley safety stock variance buffer and 1-click simulation stress presets.</a:t>
-            </a:r>
-          </a:p>
-          <a:p>
-            <a:pPr>
-              <a:spcBef>
-                <a:spcPts val="400"/>
-              </a:spcBef>
-              <a:defRPr sz="1100" b="1">
-                <a:solidFill>
-                  <a:srgbClr val="EF4444"/>
-                </a:solidFill>
-                <a:latin typeface="Calibri"/>
-              </a:defRPr>
-            </a:pPr>
-            <a:r>
-              <a:t>⚠  Operator Resistance to Complex Tools</a:t>
-            </a:r>
-          </a:p>
-          <a:p>
-            <a:pPr>
-              <a:defRPr sz="1000">
-                <a:solidFill>
-                  <a:srgbClr val="0F172A"/>
-                </a:solidFill>
-                <a:latin typeface="Calibri"/>
-              </a:defRPr>
-            </a:pPr>
-            <a:r>
-              <a:t>✓ Calm Mission Studio UI with zero clutter and single-key keyboard shortcuts.</a:t>
+              <a:t>✓ Solution &amp; Future Safeguard: Dockerized modular architecture with read-replica database pools. Future: Event-driven architecture (RabbitMQ/Kafka) for real-time inter-branch stock transfers.</a:t>
             </a:r>
           </a:p>
         </p:txBody>

</xml_diff>